<commit_message>
add coric and quake3
</commit_message>
<xml_diff>
--- a/Slides/FPforScientist.pptx
+++ b/Slides/FPforScientist.pptx
@@ -35,7 +35,8 @@
     <p:sldId id="471" r:id="rId29"/>
     <p:sldId id="474" r:id="rId30"/>
     <p:sldId id="473" r:id="rId31"/>
-    <p:sldId id="472" r:id="rId32"/>
+    <p:sldId id="475" r:id="rId32"/>
+    <p:sldId id="472" r:id="rId33"/>
   </p:sldIdLst>
   <p:sldSz cx="12192000" cy="6858000"/>
   <p:notesSz cx="6858000" cy="9144000"/>
@@ -11419,11 +11420,50 @@
             <a:pPr lvl="1"/>
             <a:r>
               <a:rPr lang="en-US" dirty="0"/>
-              <a:t>For log: compute log(1+x) in [1,2) (actually </a:t>
-            </a:r>
-            <a:r>
-              <a:rPr lang="en-US"/>
-              <a:t>an optimized [y,2y))</a:t>
+              <a:t>For log: compute log</a:t>
+            </a:r>
+            <a:r>
+              <a:rPr lang="en-US" baseline="-25000" dirty="0"/>
+              <a:t>2</a:t>
+            </a:r>
+            <a:r>
+              <a:rPr lang="en-US" dirty="0"/>
+              <a:t>(x) in [0.75,1.5)</a:t>
+            </a:r>
+          </a:p>
+          <a:p>
+            <a:pPr lvl="1"/>
+            <a:r>
+              <a:rPr lang="en-US" dirty="0"/>
+              <a:t> </a:t>
+            </a:r>
+            <a:r>
+              <a:rPr lang="en-US" dirty="0" err="1"/>
+              <a:t>x</a:t>
+            </a:r>
+            <a:r>
+              <a:rPr lang="en-US" baseline="30000" dirty="0" err="1"/>
+              <a:t>y</a:t>
+            </a:r>
+            <a:r>
+              <a:rPr lang="en-US" baseline="30000" dirty="0"/>
+              <a:t> </a:t>
+            </a:r>
+            <a:r>
+              <a:rPr lang="en-US" dirty="0"/>
+              <a:t>= 2</a:t>
+            </a:r>
+            <a:r>
+              <a:rPr lang="en-US" baseline="30000" dirty="0"/>
+              <a:t>ylog</a:t>
+            </a:r>
+            <a:r>
+              <a:rPr lang="en-US" baseline="-25000" dirty="0"/>
+              <a:t>2</a:t>
+            </a:r>
+            <a:r>
+              <a:rPr lang="en-US" baseline="30000" dirty="0"/>
+              <a:t>(x)</a:t>
             </a:r>
             <a:endParaRPr lang="en-US" dirty="0"/>
           </a:p>
@@ -12003,9 +12043,16 @@
             <p:ph idx="1"/>
           </p:nvPr>
         </p:nvSpPr>
-        <p:spPr/>
+        <p:spPr>
+          <a:xfrm>
+            <a:off x="838200" y="1365357"/>
+            <a:ext cx="10515600" cy="4783830"/>
+          </a:xfrm>
+        </p:spPr>
         <p:txBody>
-          <a:bodyPr/>
+          <a:bodyPr>
+            <a:normAutofit/>
+          </a:bodyPr>
           <a:lstStyle/>
           <a:p>
             <a:r>
@@ -12050,6 +12097,30 @@
             <a:pPr lvl="1"/>
             <a:r>
               <a:rPr lang="en-US" dirty="0"/>
+              <a:t>Shift-and-add algorithms (CORDIC </a:t>
+            </a:r>
+            <a:r>
+              <a:rPr lang="en-US" dirty="0">
+                <a:hlinkClick r:id="rId3"/>
+              </a:rPr>
+              <a:t>https://en.wikipedia.org/wiki/CORDIC</a:t>
+            </a:r>
+            <a:r>
+              <a:rPr lang="en-US" dirty="0"/>
+              <a:t>)</a:t>
+            </a:r>
+          </a:p>
+          <a:p>
+            <a:pPr lvl="2"/>
+            <a:r>
+              <a:rPr lang="en-US" dirty="0"/>
+              <a:t>Today limited to FPGA</a:t>
+            </a:r>
+          </a:p>
+          <a:p>
+            <a:pPr lvl="1"/>
+            <a:r>
+              <a:rPr lang="en-US" dirty="0"/>
               <a:t>a polynomial</a:t>
             </a:r>
           </a:p>
@@ -12080,6 +12151,30 @@
               <a:rPr lang="en-US" dirty="0"/>
               <a:t>an iterative method such as Newton-Raphson</a:t>
             </a:r>
+          </a:p>
+          <a:p>
+            <a:pPr marL="0" indent="0">
+              <a:buNone/>
+            </a:pPr>
+            <a:r>
+              <a:rPr lang="en-US" sz="1800" dirty="0"/>
+              <a:t>See also the short paper by </a:t>
+            </a:r>
+            <a:r>
+              <a:rPr lang="en-US" sz="1800" dirty="0" err="1"/>
+              <a:t>J.M.Muller</a:t>
+            </a:r>
+            <a:r>
+              <a:rPr lang="en-US" sz="1800" dirty="0"/>
+              <a:t> </a:t>
+            </a:r>
+            <a:r>
+              <a:rPr lang="en-US" sz="1800" dirty="0">
+                <a:hlinkClick r:id="rId4"/>
+              </a:rPr>
+              <a:t>https://hal.science/hal-02517784v1/file/approxfunctions.pdf</a:t>
+            </a:r>
+            <a:endParaRPr lang="en-US" sz="1800" dirty="0"/>
           </a:p>
         </p:txBody>
       </p:sp>
@@ -12097,6 +12192,686 @@
 </file>
 
 <file path=ppt/slides/slide31.xml><?xml version="1.0" encoding="utf-8"?>
+<p:sld xmlns:a="http://schemas.openxmlformats.org/drawingml/2006/main" xmlns:r="http://schemas.openxmlformats.org/officeDocument/2006/relationships" xmlns:p="http://schemas.openxmlformats.org/presentationml/2006/main">
+  <p:cSld>
+    <p:spTree>
+      <p:nvGrpSpPr>
+        <p:cNvPr id="1" name=""/>
+        <p:cNvGrpSpPr/>
+        <p:nvPr/>
+      </p:nvGrpSpPr>
+      <p:grpSpPr>
+        <a:xfrm>
+          <a:off x="0" y="0"/>
+          <a:ext cx="0" cy="0"/>
+          <a:chOff x="0" y="0"/>
+          <a:chExt cx="0" cy="0"/>
+        </a:xfrm>
+      </p:grpSpPr>
+      <p:sp>
+        <p:nvSpPr>
+          <p:cNvPr id="2" name="Title 1">
+            <a:extLst>
+              <a:ext uri="{FF2B5EF4-FFF2-40B4-BE49-F238E27FC236}">
+                <a16:creationId xmlns:a16="http://schemas.microsoft.com/office/drawing/2014/main" id="{4867C1BC-635C-B440-306B-771A7D70363C}"/>
+              </a:ext>
+            </a:extLst>
+          </p:cNvPr>
+          <p:cNvSpPr>
+            <a:spLocks noGrp="1"/>
+          </p:cNvSpPr>
+          <p:nvPr>
+            <p:ph type="title"/>
+          </p:nvPr>
+        </p:nvSpPr>
+        <p:spPr/>
+        <p:txBody>
+          <a:bodyPr/>
+          <a:lstStyle/>
+          <a:p>
+            <a:r>
+              <a:rPr lang="en-US" dirty="0"/>
+              <a:t>1/x,</a:t>
+            </a:r>
+            <a:r>
+              <a:rPr lang="en-US" altLang="en-US" dirty="0">
+                <a:ea typeface="ＭＳ Ｐゴシック" panose="020B0600070205080204" pitchFamily="34" charset="-128"/>
+              </a:rPr>
+              <a:t> √</a:t>
+            </a:r>
+            <a:r>
+              <a:rPr lang="en-US" dirty="0"/>
+              <a:t>(x),1/</a:t>
+            </a:r>
+            <a:r>
+              <a:rPr lang="en-US" altLang="en-US" dirty="0">
+                <a:ea typeface="ＭＳ Ｐゴシック" panose="020B0600070205080204" pitchFamily="34" charset="-128"/>
+              </a:rPr>
+              <a:t>√</a:t>
+            </a:r>
+            <a:r>
+              <a:rPr lang="en-US" dirty="0"/>
+              <a:t>(x) aka </a:t>
+            </a:r>
+            <a:r>
+              <a:rPr lang="en-US" dirty="0" err="1"/>
+              <a:t>rcp</a:t>
+            </a:r>
+            <a:r>
+              <a:rPr lang="en-US" dirty="0"/>
+              <a:t>(x),sqrt(x),</a:t>
+            </a:r>
+            <a:r>
+              <a:rPr lang="en-US" dirty="0" err="1"/>
+              <a:t>rsqrt</a:t>
+            </a:r>
+            <a:r>
+              <a:rPr lang="en-US" dirty="0"/>
+              <a:t>(x)</a:t>
+            </a:r>
+          </a:p>
+        </p:txBody>
+      </p:sp>
+      <p:sp>
+        <p:nvSpPr>
+          <p:cNvPr id="3" name="Content Placeholder 2">
+            <a:extLst>
+              <a:ext uri="{FF2B5EF4-FFF2-40B4-BE49-F238E27FC236}">
+                <a16:creationId xmlns:a16="http://schemas.microsoft.com/office/drawing/2014/main" id="{6FB48287-65FB-35C0-3D99-A7760E441E38}"/>
+              </a:ext>
+            </a:extLst>
+          </p:cNvPr>
+          <p:cNvSpPr>
+            <a:spLocks noGrp="1"/>
+          </p:cNvSpPr>
+          <p:nvPr>
+            <p:ph idx="1"/>
+          </p:nvPr>
+        </p:nvSpPr>
+        <p:spPr>
+          <a:xfrm>
+            <a:off x="838200" y="1641518"/>
+            <a:ext cx="10515600" cy="2476350"/>
+          </a:xfrm>
+        </p:spPr>
+        <p:txBody>
+          <a:bodyPr>
+            <a:normAutofit/>
+          </a:bodyPr>
+          <a:lstStyle/>
+          <a:p>
+            <a:r>
+              <a:rPr lang="en-US" dirty="0"/>
+              <a:t>Few fast converging Newton-Raphson iterations</a:t>
+            </a:r>
+          </a:p>
+          <a:p>
+            <a:pPr lvl="1"/>
+            <a:r>
+              <a:rPr lang="en-US" dirty="0"/>
+              <a:t>Starting point is an approximation of  </a:t>
+            </a:r>
+            <a:r>
+              <a:rPr lang="en-US" i="1" dirty="0"/>
+              <a:t>f</a:t>
+            </a:r>
+            <a:r>
+              <a:rPr lang="en-US" dirty="0"/>
+              <a:t>(1.m) </a:t>
+            </a:r>
+          </a:p>
+          <a:p>
+            <a:pPr marL="0" indent="0">
+              <a:buNone/>
+            </a:pPr>
+            <a:endParaRPr lang="en-US" dirty="0"/>
+          </a:p>
+          <a:p>
+            <a:pPr marL="0" indent="0">
+              <a:buNone/>
+            </a:pPr>
+            <a:r>
+              <a:rPr lang="en-US" dirty="0"/>
+              <a:t> </a:t>
+            </a:r>
+          </a:p>
+        </p:txBody>
+      </p:sp>
+      <p:sp>
+        <p:nvSpPr>
+          <p:cNvPr id="5" name="Content Placeholder 2">
+            <a:extLst>
+              <a:ext uri="{FF2B5EF4-FFF2-40B4-BE49-F238E27FC236}">
+                <a16:creationId xmlns:a16="http://schemas.microsoft.com/office/drawing/2014/main" id="{0ECB73D8-E6ED-0730-F110-9A5324BBB611}"/>
+              </a:ext>
+            </a:extLst>
+          </p:cNvPr>
+          <p:cNvSpPr txBox="1">
+            <a:spLocks/>
+          </p:cNvSpPr>
+          <p:nvPr/>
+        </p:nvSpPr>
+        <p:spPr>
+          <a:xfrm>
+            <a:off x="1470814" y="2675694"/>
+            <a:ext cx="8458200" cy="1066800"/>
+          </a:xfrm>
+          <a:prstGeom prst="rect">
+            <a:avLst/>
+          </a:prstGeom>
+        </p:spPr>
+        <p:txBody>
+          <a:bodyPr vert="horz" lIns="91440" tIns="45720" rIns="91440" bIns="45720" rtlCol="0">
+            <a:normAutofit/>
+          </a:bodyPr>
+          <a:lstStyle>
+            <a:lvl1pPr marL="228600" indent="-228600" algn="l" defTabSz="914400" rtl="0" eaLnBrk="1" latinLnBrk="0" hangingPunct="1">
+              <a:lnSpc>
+                <a:spcPct val="90000"/>
+              </a:lnSpc>
+              <a:spcBef>
+                <a:spcPts val="1000"/>
+              </a:spcBef>
+              <a:buFont typeface="Arial" panose="020B0604020202020204" pitchFamily="34" charset="0"/>
+              <a:buChar char="•"/>
+              <a:defRPr sz="2800" kern="1200">
+                <a:solidFill>
+                  <a:schemeClr val="tx1"/>
+                </a:solidFill>
+                <a:latin typeface="+mn-lt"/>
+                <a:ea typeface="+mn-ea"/>
+                <a:cs typeface="+mn-cs"/>
+              </a:defRPr>
+            </a:lvl1pPr>
+            <a:lvl2pPr marL="685800" indent="-228600" algn="l" defTabSz="914400" rtl="0" eaLnBrk="1" latinLnBrk="0" hangingPunct="1">
+              <a:lnSpc>
+                <a:spcPct val="90000"/>
+              </a:lnSpc>
+              <a:spcBef>
+                <a:spcPts val="500"/>
+              </a:spcBef>
+              <a:buFont typeface="Arial" panose="020B0604020202020204" pitchFamily="34" charset="0"/>
+              <a:buChar char="•"/>
+              <a:defRPr sz="2400" kern="1200">
+                <a:solidFill>
+                  <a:schemeClr val="tx1"/>
+                </a:solidFill>
+                <a:latin typeface="+mn-lt"/>
+                <a:ea typeface="+mn-ea"/>
+                <a:cs typeface="+mn-cs"/>
+              </a:defRPr>
+            </a:lvl2pPr>
+            <a:lvl3pPr marL="1143000" indent="-228600" algn="l" defTabSz="914400" rtl="0" eaLnBrk="1" latinLnBrk="0" hangingPunct="1">
+              <a:lnSpc>
+                <a:spcPct val="90000"/>
+              </a:lnSpc>
+              <a:spcBef>
+                <a:spcPts val="500"/>
+              </a:spcBef>
+              <a:buFont typeface="Arial" panose="020B0604020202020204" pitchFamily="34" charset="0"/>
+              <a:buChar char="•"/>
+              <a:defRPr sz="2000" kern="1200">
+                <a:solidFill>
+                  <a:schemeClr val="tx1"/>
+                </a:solidFill>
+                <a:latin typeface="+mn-lt"/>
+                <a:ea typeface="+mn-ea"/>
+                <a:cs typeface="+mn-cs"/>
+              </a:defRPr>
+            </a:lvl3pPr>
+            <a:lvl4pPr marL="1600200" indent="-228600" algn="l" defTabSz="914400" rtl="0" eaLnBrk="1" latinLnBrk="0" hangingPunct="1">
+              <a:lnSpc>
+                <a:spcPct val="90000"/>
+              </a:lnSpc>
+              <a:spcBef>
+                <a:spcPts val="500"/>
+              </a:spcBef>
+              <a:buFont typeface="Arial" panose="020B0604020202020204" pitchFamily="34" charset="0"/>
+              <a:buChar char="•"/>
+              <a:defRPr sz="1800" kern="1200">
+                <a:solidFill>
+                  <a:schemeClr val="tx1"/>
+                </a:solidFill>
+                <a:latin typeface="+mn-lt"/>
+                <a:ea typeface="+mn-ea"/>
+                <a:cs typeface="+mn-cs"/>
+              </a:defRPr>
+            </a:lvl4pPr>
+            <a:lvl5pPr marL="2057400" indent="-228600" algn="l" defTabSz="914400" rtl="0" eaLnBrk="1" latinLnBrk="0" hangingPunct="1">
+              <a:lnSpc>
+                <a:spcPct val="90000"/>
+              </a:lnSpc>
+              <a:spcBef>
+                <a:spcPts val="500"/>
+              </a:spcBef>
+              <a:buFont typeface="Arial" panose="020B0604020202020204" pitchFamily="34" charset="0"/>
+              <a:buChar char="•"/>
+              <a:defRPr sz="1800" kern="1200">
+                <a:solidFill>
+                  <a:schemeClr val="tx1"/>
+                </a:solidFill>
+                <a:latin typeface="+mn-lt"/>
+                <a:ea typeface="+mn-ea"/>
+                <a:cs typeface="+mn-cs"/>
+              </a:defRPr>
+            </a:lvl5pPr>
+            <a:lvl6pPr marL="2514600" indent="-228600" algn="l" defTabSz="914400" rtl="0" eaLnBrk="1" latinLnBrk="0" hangingPunct="1">
+              <a:lnSpc>
+                <a:spcPct val="90000"/>
+              </a:lnSpc>
+              <a:spcBef>
+                <a:spcPts val="500"/>
+              </a:spcBef>
+              <a:buFont typeface="Arial" panose="020B0604020202020204" pitchFamily="34" charset="0"/>
+              <a:buChar char="•"/>
+              <a:defRPr sz="1800" kern="1200">
+                <a:solidFill>
+                  <a:schemeClr val="tx1"/>
+                </a:solidFill>
+                <a:latin typeface="+mn-lt"/>
+                <a:ea typeface="+mn-ea"/>
+                <a:cs typeface="+mn-cs"/>
+              </a:defRPr>
+            </a:lvl6pPr>
+            <a:lvl7pPr marL="2971800" indent="-228600" algn="l" defTabSz="914400" rtl="0" eaLnBrk="1" latinLnBrk="0" hangingPunct="1">
+              <a:lnSpc>
+                <a:spcPct val="90000"/>
+              </a:lnSpc>
+              <a:spcBef>
+                <a:spcPts val="500"/>
+              </a:spcBef>
+              <a:buFont typeface="Arial" panose="020B0604020202020204" pitchFamily="34" charset="0"/>
+              <a:buChar char="•"/>
+              <a:defRPr sz="1800" kern="1200">
+                <a:solidFill>
+                  <a:schemeClr val="tx1"/>
+                </a:solidFill>
+                <a:latin typeface="+mn-lt"/>
+                <a:ea typeface="+mn-ea"/>
+                <a:cs typeface="+mn-cs"/>
+              </a:defRPr>
+            </a:lvl7pPr>
+            <a:lvl8pPr marL="3429000" indent="-228600" algn="l" defTabSz="914400" rtl="0" eaLnBrk="1" latinLnBrk="0" hangingPunct="1">
+              <a:lnSpc>
+                <a:spcPct val="90000"/>
+              </a:lnSpc>
+              <a:spcBef>
+                <a:spcPts val="500"/>
+              </a:spcBef>
+              <a:buFont typeface="Arial" panose="020B0604020202020204" pitchFamily="34" charset="0"/>
+              <a:buChar char="•"/>
+              <a:defRPr sz="1800" kern="1200">
+                <a:solidFill>
+                  <a:schemeClr val="tx1"/>
+                </a:solidFill>
+                <a:latin typeface="+mn-lt"/>
+                <a:ea typeface="+mn-ea"/>
+                <a:cs typeface="+mn-cs"/>
+              </a:defRPr>
+            </a:lvl8pPr>
+            <a:lvl9pPr marL="3886200" indent="-228600" algn="l" defTabSz="914400" rtl="0" eaLnBrk="1" latinLnBrk="0" hangingPunct="1">
+              <a:lnSpc>
+                <a:spcPct val="90000"/>
+              </a:lnSpc>
+              <a:spcBef>
+                <a:spcPts val="500"/>
+              </a:spcBef>
+              <a:buFont typeface="Arial" panose="020B0604020202020204" pitchFamily="34" charset="0"/>
+              <a:buChar char="•"/>
+              <a:defRPr sz="1800" kern="1200">
+                <a:solidFill>
+                  <a:schemeClr val="tx1"/>
+                </a:solidFill>
+                <a:latin typeface="+mn-lt"/>
+                <a:ea typeface="+mn-ea"/>
+                <a:cs typeface="+mn-cs"/>
+              </a:defRPr>
+            </a:lvl9pPr>
+          </a:lstStyle>
+          <a:p>
+            <a:pPr>
+              <a:buFont typeface="Wingdings" pitchFamily="2" charset="2"/>
+              <a:buNone/>
+            </a:pPr>
+            <a:r>
+              <a:rPr lang="en-US" altLang="en-US" dirty="0">
+                <a:ea typeface="ＭＳ Ｐゴシック" panose="020B0600070205080204" pitchFamily="34" charset="-128"/>
+              </a:rPr>
+              <a:t>The major contribution of game industry to SE is the discovery of the “magic” fast 1/√x algorithm </a:t>
+            </a:r>
+            <a:r>
+              <a:rPr lang="en-US" altLang="en-US">
+                <a:ea typeface="ＭＳ Ｐゴシック" panose="020B0600070205080204" pitchFamily="34" charset="-128"/>
+              </a:rPr>
+              <a:t>in quake3</a:t>
+            </a:r>
+            <a:endParaRPr lang="en-US" altLang="en-US" dirty="0">
+              <a:ea typeface="ＭＳ Ｐゴシック" panose="020B0600070205080204" pitchFamily="34" charset="-128"/>
+            </a:endParaRPr>
+          </a:p>
+        </p:txBody>
+      </p:sp>
+      <p:sp>
+        <p:nvSpPr>
+          <p:cNvPr id="7" name="TextBox 6">
+            <a:extLst>
+              <a:ext uri="{FF2B5EF4-FFF2-40B4-BE49-F238E27FC236}">
+                <a16:creationId xmlns:a16="http://schemas.microsoft.com/office/drawing/2014/main" id="{301FB198-5BA2-7463-B22E-2D8A8537B04C}"/>
+              </a:ext>
+            </a:extLst>
+          </p:cNvPr>
+          <p:cNvSpPr txBox="1">
+            <a:spLocks noChangeArrowheads="1"/>
+          </p:cNvSpPr>
+          <p:nvPr/>
+        </p:nvSpPr>
+        <p:spPr bwMode="auto">
+          <a:xfrm>
+            <a:off x="270024" y="3742494"/>
+            <a:ext cx="4648200" cy="2032000"/>
+          </a:xfrm>
+          <a:prstGeom prst="rect">
+            <a:avLst/>
+          </a:prstGeom>
+          <a:solidFill>
+            <a:srgbClr val="FFFF00">
+              <a:alpha val="20000"/>
+            </a:srgbClr>
+          </a:solidFill>
+          <a:ln>
+            <a:noFill/>
+          </a:ln>
+          <a:extLst>
+            <a:ext uri="{91240B29-F687-4F45-9708-019B960494DF}">
+              <a14:hiddenLine xmlns:a14="http://schemas.microsoft.com/office/drawing/2010/main" w="9525">
+                <a:solidFill>
+                  <a:srgbClr val="000000"/>
+                </a:solidFill>
+                <a:miter lim="800000"/>
+                <a:headEnd/>
+                <a:tailEnd/>
+              </a14:hiddenLine>
+            </a:ext>
+          </a:extLst>
+        </p:spPr>
+        <p:txBody>
+          <a:bodyPr>
+            <a:spAutoFit/>
+          </a:bodyPr>
+          <a:lstStyle>
+            <a:lvl1pPr eaLnBrk="0" hangingPunct="0">
+              <a:defRPr sz="2400">
+                <a:solidFill>
+                  <a:schemeClr val="tx1"/>
+                </a:solidFill>
+                <a:latin typeface="Arial" panose="020B0604020202020204" pitchFamily="34" charset="0"/>
+                <a:ea typeface="ＭＳ Ｐゴシック" panose="020B0600070205080204" pitchFamily="34" charset="-128"/>
+              </a:defRPr>
+            </a:lvl1pPr>
+            <a:lvl2pPr marL="742950" indent="-285750" eaLnBrk="0" hangingPunct="0">
+              <a:defRPr sz="2400">
+                <a:solidFill>
+                  <a:schemeClr val="tx1"/>
+                </a:solidFill>
+                <a:latin typeface="Arial" panose="020B0604020202020204" pitchFamily="34" charset="0"/>
+                <a:ea typeface="ＭＳ Ｐゴシック" panose="020B0600070205080204" pitchFamily="34" charset="-128"/>
+              </a:defRPr>
+            </a:lvl2pPr>
+            <a:lvl3pPr marL="1143000" indent="-228600" eaLnBrk="0" hangingPunct="0">
+              <a:defRPr sz="2400">
+                <a:solidFill>
+                  <a:schemeClr val="tx1"/>
+                </a:solidFill>
+                <a:latin typeface="Arial" panose="020B0604020202020204" pitchFamily="34" charset="0"/>
+                <a:ea typeface="ＭＳ Ｐゴシック" panose="020B0600070205080204" pitchFamily="34" charset="-128"/>
+              </a:defRPr>
+            </a:lvl3pPr>
+            <a:lvl4pPr marL="1600200" indent="-228600" eaLnBrk="0" hangingPunct="0">
+              <a:defRPr sz="2400">
+                <a:solidFill>
+                  <a:schemeClr val="tx1"/>
+                </a:solidFill>
+                <a:latin typeface="Arial" panose="020B0604020202020204" pitchFamily="34" charset="0"/>
+                <a:ea typeface="ＭＳ Ｐゴシック" panose="020B0600070205080204" pitchFamily="34" charset="-128"/>
+              </a:defRPr>
+            </a:lvl4pPr>
+            <a:lvl5pPr marL="2057400" indent="-228600" eaLnBrk="0" hangingPunct="0">
+              <a:defRPr sz="2400">
+                <a:solidFill>
+                  <a:schemeClr val="tx1"/>
+                </a:solidFill>
+                <a:latin typeface="Arial" panose="020B0604020202020204" pitchFamily="34" charset="0"/>
+                <a:ea typeface="ＭＳ Ｐゴシック" panose="020B0600070205080204" pitchFamily="34" charset="-128"/>
+              </a:defRPr>
+            </a:lvl5pPr>
+            <a:lvl6pPr marL="2514600" indent="-228600" eaLnBrk="0" fontAlgn="base" hangingPunct="0">
+              <a:spcBef>
+                <a:spcPct val="0"/>
+              </a:spcBef>
+              <a:spcAft>
+                <a:spcPct val="0"/>
+              </a:spcAft>
+              <a:defRPr sz="2400">
+                <a:solidFill>
+                  <a:schemeClr val="tx1"/>
+                </a:solidFill>
+                <a:latin typeface="Arial" panose="020B0604020202020204" pitchFamily="34" charset="0"/>
+                <a:ea typeface="ＭＳ Ｐゴシック" panose="020B0600070205080204" pitchFamily="34" charset="-128"/>
+              </a:defRPr>
+            </a:lvl6pPr>
+            <a:lvl7pPr marL="2971800" indent="-228600" eaLnBrk="0" fontAlgn="base" hangingPunct="0">
+              <a:spcBef>
+                <a:spcPct val="0"/>
+              </a:spcBef>
+              <a:spcAft>
+                <a:spcPct val="0"/>
+              </a:spcAft>
+              <a:defRPr sz="2400">
+                <a:solidFill>
+                  <a:schemeClr val="tx1"/>
+                </a:solidFill>
+                <a:latin typeface="Arial" panose="020B0604020202020204" pitchFamily="34" charset="0"/>
+                <a:ea typeface="ＭＳ Ｐゴシック" panose="020B0600070205080204" pitchFamily="34" charset="-128"/>
+              </a:defRPr>
+            </a:lvl7pPr>
+            <a:lvl8pPr marL="3429000" indent="-228600" eaLnBrk="0" fontAlgn="base" hangingPunct="0">
+              <a:spcBef>
+                <a:spcPct val="0"/>
+              </a:spcBef>
+              <a:spcAft>
+                <a:spcPct val="0"/>
+              </a:spcAft>
+              <a:defRPr sz="2400">
+                <a:solidFill>
+                  <a:schemeClr val="tx1"/>
+                </a:solidFill>
+                <a:latin typeface="Arial" panose="020B0604020202020204" pitchFamily="34" charset="0"/>
+                <a:ea typeface="ＭＳ Ｐゴシック" panose="020B0600070205080204" pitchFamily="34" charset="-128"/>
+              </a:defRPr>
+            </a:lvl8pPr>
+            <a:lvl9pPr marL="3886200" indent="-228600" eaLnBrk="0" fontAlgn="base" hangingPunct="0">
+              <a:spcBef>
+                <a:spcPct val="0"/>
+              </a:spcBef>
+              <a:spcAft>
+                <a:spcPct val="0"/>
+              </a:spcAft>
+              <a:defRPr sz="2400">
+                <a:solidFill>
+                  <a:schemeClr val="tx1"/>
+                </a:solidFill>
+                <a:latin typeface="Arial" panose="020B0604020202020204" pitchFamily="34" charset="0"/>
+                <a:ea typeface="ＭＳ Ｐゴシック" panose="020B0600070205080204" pitchFamily="34" charset="-128"/>
+              </a:defRPr>
+            </a:lvl9pPr>
+          </a:lstStyle>
+          <a:p>
+            <a:pPr eaLnBrk="1" hangingPunct="1"/>
+            <a:r>
+              <a:rPr lang="en-US" altLang="en-US" sz="1800" dirty="0"/>
+              <a:t>float </a:t>
+            </a:r>
+            <a:r>
+              <a:rPr lang="en-US" altLang="en-US" sz="1800" dirty="0" err="1"/>
+              <a:t>rsqrt</a:t>
+            </a:r>
+            <a:r>
+              <a:rPr lang="en-US" altLang="en-US" sz="1800" dirty="0"/>
+              <a:t>(float x){</a:t>
+            </a:r>
+          </a:p>
+          <a:p>
+            <a:pPr eaLnBrk="1" hangingPunct="1"/>
+            <a:r>
+              <a:rPr lang="en-US" altLang="en-US" sz="1800" dirty="0"/>
+              <a:t>  union {float </a:t>
+            </a:r>
+            <a:r>
+              <a:rPr lang="en-US" altLang="en-US" sz="1800" dirty="0" err="1"/>
+              <a:t>f;int</a:t>
+            </a:r>
+            <a:r>
+              <a:rPr lang="en-US" altLang="en-US" sz="1800" dirty="0"/>
+              <a:t> </a:t>
+            </a:r>
+            <a:r>
+              <a:rPr lang="en-US" altLang="en-US" sz="1800" dirty="0" err="1"/>
+              <a:t>i</a:t>
+            </a:r>
+            <a:r>
+              <a:rPr lang="en-US" altLang="en-US" sz="1800" dirty="0"/>
+              <a:t>;} </a:t>
+            </a:r>
+            <a:r>
+              <a:rPr lang="en-US" altLang="en-US" sz="1800" dirty="0" err="1"/>
+              <a:t>tmp</a:t>
+            </a:r>
+            <a:r>
+              <a:rPr lang="en-US" altLang="en-US" sz="1800" dirty="0"/>
+              <a:t>;</a:t>
+            </a:r>
+          </a:p>
+          <a:p>
+            <a:pPr eaLnBrk="1" hangingPunct="1"/>
+            <a:r>
+              <a:rPr lang="en-US" altLang="en-US" sz="1800" dirty="0"/>
+              <a:t>  </a:t>
+            </a:r>
+            <a:r>
+              <a:rPr lang="en-US" altLang="en-US" sz="1800" dirty="0" err="1"/>
+              <a:t>tmp.f</a:t>
+            </a:r>
+            <a:r>
+              <a:rPr lang="en-US" altLang="en-US" sz="1800" dirty="0"/>
+              <a:t> = x;</a:t>
+            </a:r>
+          </a:p>
+          <a:p>
+            <a:pPr eaLnBrk="1" hangingPunct="1"/>
+            <a:r>
+              <a:rPr lang="en-US" altLang="en-US" sz="1800" dirty="0"/>
+              <a:t>  </a:t>
+            </a:r>
+            <a:r>
+              <a:rPr lang="en-US" altLang="en-US" sz="1800" dirty="0" err="1"/>
+              <a:t>tmp.i</a:t>
+            </a:r>
+            <a:r>
+              <a:rPr lang="en-US" altLang="en-US" sz="1800" dirty="0"/>
+              <a:t> = 0x5f3759df - (</a:t>
+            </a:r>
+            <a:r>
+              <a:rPr lang="en-US" altLang="en-US" sz="1800" dirty="0" err="1"/>
+              <a:t>tmp.i</a:t>
+            </a:r>
+            <a:r>
+              <a:rPr lang="en-US" altLang="en-US" sz="1800" dirty="0"/>
+              <a:t> &gt;&gt; 1);</a:t>
+            </a:r>
+          </a:p>
+          <a:p>
+            <a:pPr eaLnBrk="1" hangingPunct="1"/>
+            <a:r>
+              <a:rPr lang="en-US" altLang="en-US" sz="1800" dirty="0"/>
+              <a:t>  float y = </a:t>
+            </a:r>
+            <a:r>
+              <a:rPr lang="en-US" altLang="en-US" sz="1800" dirty="0" err="1"/>
+              <a:t>tmp.f</a:t>
+            </a:r>
+            <a:r>
+              <a:rPr lang="en-US" altLang="en-US" sz="1800" dirty="0"/>
+              <a:t>; // approximate</a:t>
+            </a:r>
+          </a:p>
+          <a:p>
+            <a:pPr eaLnBrk="1" hangingPunct="1"/>
+            <a:r>
+              <a:rPr lang="en-US" altLang="en-US" sz="1800" dirty="0"/>
+              <a:t>  return y * (1.5f - 0.5f * x * y * y); // NR</a:t>
+            </a:r>
+          </a:p>
+          <a:p>
+            <a:pPr eaLnBrk="1" hangingPunct="1"/>
+            <a:r>
+              <a:rPr lang="en-US" altLang="en-US" sz="1800" dirty="0"/>
+              <a:t>}</a:t>
+            </a:r>
+          </a:p>
+        </p:txBody>
+      </p:sp>
+      <p:sp>
+        <p:nvSpPr>
+          <p:cNvPr id="8" name="TextBox 7">
+            <a:extLst>
+              <a:ext uri="{FF2B5EF4-FFF2-40B4-BE49-F238E27FC236}">
+                <a16:creationId xmlns:a16="http://schemas.microsoft.com/office/drawing/2014/main" id="{A2FE26A6-BE0B-DF7E-E51E-058EF259F85F}"/>
+              </a:ext>
+            </a:extLst>
+          </p:cNvPr>
+          <p:cNvSpPr txBox="1"/>
+          <p:nvPr/>
+        </p:nvSpPr>
+        <p:spPr>
+          <a:xfrm>
+            <a:off x="259450" y="5849512"/>
+            <a:ext cx="5440464" cy="369332"/>
+          </a:xfrm>
+          <a:prstGeom prst="rect">
+            <a:avLst/>
+          </a:prstGeom>
+          <a:noFill/>
+        </p:spPr>
+        <p:txBody>
+          <a:bodyPr wrap="none" rtlCol="0">
+            <a:spAutoFit/>
+          </a:bodyPr>
+          <a:lstStyle/>
+          <a:p>
+            <a:r>
+              <a:rPr lang="en-US" dirty="0">
+                <a:hlinkClick r:id="rId2"/>
+              </a:rPr>
+              <a:t>https://en.wikipedia.org/wiki/Fast_inverse_square_root</a:t>
+            </a:r>
+            <a:endParaRPr lang="en-US" dirty="0"/>
+          </a:p>
+        </p:txBody>
+      </p:sp>
+    </p:spTree>
+    <p:extLst>
+      <p:ext uri="{BB962C8B-B14F-4D97-AF65-F5344CB8AC3E}">
+        <p14:creationId xmlns:p14="http://schemas.microsoft.com/office/powerpoint/2010/main" val="3971333510"/>
+      </p:ext>
+    </p:extLst>
+  </p:cSld>
+  <p:clrMapOvr>
+    <a:masterClrMapping/>
+  </p:clrMapOvr>
+</p:sld>
+</file>
+
+<file path=ppt/slides/slide32.xml><?xml version="1.0" encoding="utf-8"?>
 <p:sld xmlns:a="http://schemas.openxmlformats.org/drawingml/2006/main" xmlns:r="http://schemas.openxmlformats.org/officeDocument/2006/relationships" xmlns:p="http://schemas.openxmlformats.org/presentationml/2006/main">
   <p:cSld>
     <p:spTree>

</xml_diff>

<commit_message>
get range reduction right
</commit_message>
<xml_diff>
--- a/Slides/FPforScientist.pptx
+++ b/Slides/FPforScientist.pptx
@@ -6258,6 +6258,53 @@
           </a:p>
         </p:txBody>
       </p:sp>
+      <p:pic>
+        <p:nvPicPr>
+          <p:cNvPr id="6" name="Picture 2">
+            <a:extLst>
+              <a:ext uri="{FF2B5EF4-FFF2-40B4-BE49-F238E27FC236}">
+                <a16:creationId xmlns:a16="http://schemas.microsoft.com/office/drawing/2014/main" id="{A397D800-2A5D-8DE1-A99F-EB71EAD3AAEF}"/>
+              </a:ext>
+            </a:extLst>
+          </p:cNvPr>
+          <p:cNvPicPr>
+            <a:picLocks noChangeAspect="1" noChangeArrowheads="1"/>
+          </p:cNvPicPr>
+          <p:nvPr/>
+        </p:nvPicPr>
+        <p:blipFill>
+          <a:blip r:embed="rId4">
+            <a:extLst>
+              <a:ext uri="{28A0092B-C50C-407E-A947-70E740481C1C}">
+                <a14:useLocalDpi xmlns:a14="http://schemas.microsoft.com/office/drawing/2010/main" val="0"/>
+              </a:ext>
+            </a:extLst>
+          </a:blip>
+          <a:srcRect/>
+          <a:stretch>
+            <a:fillRect/>
+          </a:stretch>
+        </p:blipFill>
+        <p:spPr bwMode="auto">
+          <a:xfrm>
+            <a:off x="8684441" y="99724"/>
+            <a:ext cx="3433957" cy="2993280"/>
+          </a:xfrm>
+          <a:prstGeom prst="rect">
+            <a:avLst/>
+          </a:prstGeom>
+          <a:noFill/>
+          <a:extLst>
+            <a:ext uri="{909E8E84-426E-40DD-AFC4-6F175D3DCCD1}">
+              <a14:hiddenFill xmlns:a14="http://schemas.microsoft.com/office/drawing/2010/main">
+                <a:solidFill>
+                  <a:srgbClr val="FFFFFF"/>
+                </a:solidFill>
+              </a14:hiddenFill>
+            </a:ext>
+          </a:extLst>
+        </p:spPr>
+      </p:pic>
     </p:spTree>
     <p:extLst>
       <p:ext uri="{BB962C8B-B14F-4D97-AF65-F5344CB8AC3E}">
@@ -6335,63 +6382,63 @@
           <a:lstStyle/>
           <a:p>
             <a:r>
-              <a:rPr lang="en-US"/>
+              <a:rPr lang="en-US" dirty="0"/>
               <a:t>Count the number of FP in a </a:t>
             </a:r>
             <a:r>
-              <a:rPr lang="en-US" err="1"/>
+              <a:rPr lang="en-US" dirty="0" err="1"/>
               <a:t>binade</a:t>
             </a:r>
-            <a:endParaRPr lang="en-US"/>
+            <a:endParaRPr lang="en-US" dirty="0"/>
           </a:p>
           <a:p>
             <a:pPr lvl="1"/>
             <a:r>
-              <a:rPr lang="en-US"/>
+              <a:rPr lang="en-US" dirty="0"/>
               <a:t>Verify that they are the same for two different </a:t>
             </a:r>
             <a:r>
-              <a:rPr lang="en-US" err="1"/>
+              <a:rPr lang="en-US" dirty="0" err="1"/>
               <a:t>binades</a:t>
             </a:r>
-            <a:endParaRPr lang="en-US"/>
-          </a:p>
-          <a:p>
-            <a:r>
-              <a:rPr lang="en-US"/>
+            <a:endParaRPr lang="en-US" dirty="0"/>
+          </a:p>
+          <a:p>
+            <a:r>
+              <a:rPr lang="en-US" dirty="0"/>
               <a:t>Compute the ULP for some FPs</a:t>
             </a:r>
           </a:p>
           <a:p>
             <a:pPr lvl="1"/>
             <a:r>
-              <a:rPr lang="en-US"/>
+              <a:rPr lang="en-US" dirty="0"/>
               <a:t>How it depends on the </a:t>
             </a:r>
             <a:r>
-              <a:rPr lang="en-US" err="1"/>
+              <a:rPr lang="en-US" dirty="0" err="1"/>
               <a:t>binade</a:t>
             </a:r>
             <a:r>
-              <a:rPr lang="en-US"/>
+              <a:rPr lang="en-US" dirty="0"/>
               <a:t>?</a:t>
             </a:r>
           </a:p>
           <a:p>
             <a:r>
-              <a:rPr lang="en-US"/>
-              <a:t>Convert some number (0.1, pi, 31.5,  …) between various representations (including decimal)</a:t>
+              <a:rPr lang="en-US" dirty="0"/>
+              <a:t>Convert some number (0.1, e, pi, 31.5,  …) between various representations (including decimal)</a:t>
             </a:r>
           </a:p>
           <a:p>
             <a:pPr lvl="1"/>
             <a:r>
-              <a:rPr lang="en-US"/>
+              <a:rPr lang="en-US" dirty="0"/>
               <a:t>See what happens and explain it</a:t>
             </a:r>
           </a:p>
           <a:p>
-            <a:endParaRPr lang="en-US"/>
+            <a:endParaRPr lang="en-US" dirty="0"/>
           </a:p>
         </p:txBody>
       </p:sp>
@@ -8368,6 +8415,53 @@
           </a:p>
         </p:txBody>
       </p:sp>
+      <p:pic>
+        <p:nvPicPr>
+          <p:cNvPr id="4098" name="Picture 2">
+            <a:extLst>
+              <a:ext uri="{FF2B5EF4-FFF2-40B4-BE49-F238E27FC236}">
+                <a16:creationId xmlns:a16="http://schemas.microsoft.com/office/drawing/2014/main" id="{4795F761-D29F-6D3D-0704-2A2B8ED29F74}"/>
+              </a:ext>
+            </a:extLst>
+          </p:cNvPr>
+          <p:cNvPicPr>
+            <a:picLocks noChangeAspect="1" noChangeArrowheads="1"/>
+          </p:cNvPicPr>
+          <p:nvPr/>
+        </p:nvPicPr>
+        <p:blipFill>
+          <a:blip r:embed="rId3">
+            <a:extLst>
+              <a:ext uri="{28A0092B-C50C-407E-A947-70E740481C1C}">
+                <a14:useLocalDpi xmlns:a14="http://schemas.microsoft.com/office/drawing/2010/main" val="0"/>
+              </a:ext>
+            </a:extLst>
+          </a:blip>
+          <a:srcRect/>
+          <a:stretch>
+            <a:fillRect/>
+          </a:stretch>
+        </p:blipFill>
+        <p:spPr bwMode="auto">
+          <a:xfrm>
+            <a:off x="8767071" y="68481"/>
+            <a:ext cx="3376067" cy="3037402"/>
+          </a:xfrm>
+          <a:prstGeom prst="rect">
+            <a:avLst/>
+          </a:prstGeom>
+          <a:noFill/>
+          <a:extLst>
+            <a:ext uri="{909E8E84-426E-40DD-AFC4-6F175D3DCCD1}">
+              <a14:hiddenFill xmlns:a14="http://schemas.microsoft.com/office/drawing/2010/main">
+                <a:solidFill>
+                  <a:srgbClr val="FFFFFF"/>
+                </a:solidFill>
+              </a14:hiddenFill>
+            </a:ext>
+          </a:extLst>
+        </p:spPr>
+      </p:pic>
     </p:spTree>
     <p:extLst>
       <p:ext uri="{BB962C8B-B14F-4D97-AF65-F5344CB8AC3E}">
@@ -9891,6 +9985,53 @@
           </a:p>
         </p:txBody>
       </p:sp>
+      <p:pic>
+        <p:nvPicPr>
+          <p:cNvPr id="6146" name="Picture 2">
+            <a:extLst>
+              <a:ext uri="{FF2B5EF4-FFF2-40B4-BE49-F238E27FC236}">
+                <a16:creationId xmlns:a16="http://schemas.microsoft.com/office/drawing/2014/main" id="{1F68500B-495C-0FA3-7CB7-25F805161600}"/>
+              </a:ext>
+            </a:extLst>
+          </p:cNvPr>
+          <p:cNvPicPr>
+            <a:picLocks noChangeAspect="1" noChangeArrowheads="1"/>
+          </p:cNvPicPr>
+          <p:nvPr/>
+        </p:nvPicPr>
+        <p:blipFill>
+          <a:blip r:embed="rId4">
+            <a:extLst>
+              <a:ext uri="{28A0092B-C50C-407E-A947-70E740481C1C}">
+                <a14:useLocalDpi xmlns:a14="http://schemas.microsoft.com/office/drawing/2010/main" val="0"/>
+              </a:ext>
+            </a:extLst>
+          </a:blip>
+          <a:srcRect/>
+          <a:stretch>
+            <a:fillRect/>
+          </a:stretch>
+        </p:blipFill>
+        <p:spPr bwMode="auto">
+          <a:xfrm>
+            <a:off x="8684441" y="99724"/>
+            <a:ext cx="3433957" cy="2993280"/>
+          </a:xfrm>
+          <a:prstGeom prst="rect">
+            <a:avLst/>
+          </a:prstGeom>
+          <a:noFill/>
+          <a:extLst>
+            <a:ext uri="{909E8E84-426E-40DD-AFC4-6F175D3DCCD1}">
+              <a14:hiddenFill xmlns:a14="http://schemas.microsoft.com/office/drawing/2010/main">
+                <a:solidFill>
+                  <a:srgbClr val="FFFFFF"/>
+                </a:solidFill>
+              </a14:hiddenFill>
+            </a:ext>
+          </a:extLst>
+        </p:spPr>
+      </p:pic>
     </p:spTree>
     <p:extLst>
       <p:ext uri="{BB962C8B-B14F-4D97-AF65-F5344CB8AC3E}">
@@ -10971,6 +11112,53 @@
           </a:p>
         </p:txBody>
       </p:sp>
+      <p:pic>
+        <p:nvPicPr>
+          <p:cNvPr id="5122" name="Picture 2">
+            <a:extLst>
+              <a:ext uri="{FF2B5EF4-FFF2-40B4-BE49-F238E27FC236}">
+                <a16:creationId xmlns:a16="http://schemas.microsoft.com/office/drawing/2014/main" id="{99B69373-28D4-967A-ED33-3BA269A491E6}"/>
+              </a:ext>
+            </a:extLst>
+          </p:cNvPr>
+          <p:cNvPicPr>
+            <a:picLocks noChangeAspect="1" noChangeArrowheads="1"/>
+          </p:cNvPicPr>
+          <p:nvPr/>
+        </p:nvPicPr>
+        <p:blipFill>
+          <a:blip r:embed="rId2">
+            <a:extLst>
+              <a:ext uri="{28A0092B-C50C-407E-A947-70E740481C1C}">
+                <a14:useLocalDpi xmlns:a14="http://schemas.microsoft.com/office/drawing/2010/main" val="0"/>
+              </a:ext>
+            </a:extLst>
+          </a:blip>
+          <a:srcRect/>
+          <a:stretch>
+            <a:fillRect/>
+          </a:stretch>
+        </p:blipFill>
+        <p:spPr bwMode="auto">
+          <a:xfrm>
+            <a:off x="2382518" y="667389"/>
+            <a:ext cx="3713482" cy="1336854"/>
+          </a:xfrm>
+          <a:prstGeom prst="rect">
+            <a:avLst/>
+          </a:prstGeom>
+          <a:noFill/>
+          <a:extLst>
+            <a:ext uri="{909E8E84-426E-40DD-AFC4-6F175D3DCCD1}">
+              <a14:hiddenFill xmlns:a14="http://schemas.microsoft.com/office/drawing/2010/main">
+                <a:solidFill>
+                  <a:srgbClr val="FFFFFF"/>
+                </a:solidFill>
+              </a14:hiddenFill>
+            </a:ext>
+          </a:extLst>
+        </p:spPr>
+      </p:pic>
     </p:spTree>
     <p:extLst>
       <p:ext uri="{BB962C8B-B14F-4D97-AF65-F5344CB8AC3E}">
@@ -11054,14 +11242,14 @@
           <a:p>
             <a:r>
               <a:rPr lang="en-US" dirty="0"/>
-              <a:t>IEEE754 defines a set of “additional operations” (aka elementary functions) to be implemented</a:t>
+              <a:t>IEEE754 defines a set of “additional operations” (aka elementary functions) </a:t>
             </a:r>
           </a:p>
           <a:p>
             <a:pPr lvl="1"/>
             <a:r>
               <a:rPr lang="en-US" dirty="0"/>
-              <a:t>exp, log, power, </a:t>
+              <a:t>exp, log, power of various forms</a:t>
             </a:r>
           </a:p>
           <a:p>
@@ -11107,7 +11295,7 @@
           <a:p>
             <a:r>
               <a:rPr lang="en-US" dirty="0"/>
-              <a:t>Each vendor and compiler provider has its own implementation</a:t>
+              <a:t>Each vendor/compiler provides its own implementation</a:t>
             </a:r>
           </a:p>
           <a:p>
@@ -11231,7 +11419,7 @@
         </p:nvSpPr>
         <p:spPr>
           <a:xfrm>
-            <a:off x="838200" y="1529062"/>
+            <a:off x="733873" y="1105615"/>
             <a:ext cx="10515600" cy="4847023"/>
           </a:xfrm>
         </p:spPr>
@@ -11248,6 +11436,10 @@
             </a:r>
           </a:p>
           <a:p>
+            <a:pPr marL="514350" indent="-514350">
+              <a:buFont typeface="+mj-lt"/>
+              <a:buAutoNum type="arabicPeriod"/>
+            </a:pPr>
             <a:r>
               <a:rPr lang="en-US" dirty="0"/>
               <a:t>Handling special values, under/over-flows and invalid</a:t>
@@ -11261,18 +11453,30 @@
             </a:r>
           </a:p>
           <a:p>
+            <a:pPr marL="514350" indent="-514350">
+              <a:buFont typeface="+mj-lt"/>
+              <a:buAutoNum type="arabicPeriod"/>
+            </a:pPr>
             <a:r>
               <a:rPr lang="en-US" dirty="0"/>
               <a:t>Range Reduction</a:t>
             </a:r>
           </a:p>
           <a:p>
+            <a:pPr marL="514350" indent="-514350">
+              <a:buFont typeface="+mj-lt"/>
+              <a:buAutoNum type="arabicPeriod"/>
+            </a:pPr>
             <a:r>
               <a:rPr lang="en-US" dirty="0"/>
               <a:t>Approximation</a:t>
             </a:r>
           </a:p>
           <a:p>
+            <a:pPr marL="514350" indent="-514350">
+              <a:buFont typeface="+mj-lt"/>
+              <a:buAutoNum type="arabicPeriod"/>
+            </a:pPr>
             <a:r>
               <a:rPr lang="en-US" dirty="0"/>
               <a:t>If required:</a:t>
@@ -11286,6 +11490,10 @@
             </a:r>
           </a:p>
           <a:p>
+            <a:pPr marL="514350" indent="-514350">
+              <a:buFont typeface="+mj-lt"/>
+              <a:buAutoNum type="arabicPeriod"/>
+            </a:pPr>
             <a:r>
               <a:rPr lang="en-US" dirty="0"/>
               <a:t>Back to full range</a:t>
@@ -11372,12 +11580,14 @@
         </p:nvSpPr>
         <p:spPr>
           <a:xfrm>
-            <a:off x="838200" y="1825625"/>
-            <a:ext cx="10826578" cy="4351338"/>
+            <a:off x="435721" y="1825625"/>
+            <a:ext cx="11310330" cy="4351338"/>
           </a:xfrm>
         </p:spPr>
         <p:txBody>
-          <a:bodyPr/>
+          <a:bodyPr>
+            <a:normAutofit/>
+          </a:bodyPr>
           <a:lstStyle/>
           <a:p>
             <a:r>
@@ -11397,46 +11607,83 @@
             </a:r>
             <a:r>
               <a:rPr lang="en-US" dirty="0"/>
-              <a:t> representation: 1.mᐧ</a:t>
+              <a:t> representation: x = 1.mᐧ</a:t>
             </a:r>
             <a:r>
               <a:rPr lang="cs-CZ" altLang="x-none" dirty="0"/>
               <a:t>2</a:t>
             </a:r>
             <a:r>
+              <a:rPr lang="en-US" altLang="x-none" baseline="30000" dirty="0"/>
+              <a:t>n</a:t>
+            </a:r>
+            <a:endParaRPr lang="en-US" baseline="30000" dirty="0"/>
+          </a:p>
+          <a:p>
+            <a:pPr lvl="1"/>
+            <a:r>
+              <a:rPr lang="en-US" dirty="0"/>
+              <a:t>For exp(x):  x = </a:t>
+            </a:r>
+            <a:r>
+              <a:rPr lang="en-US" dirty="0" err="1"/>
+              <a:t>kᐧlog</a:t>
+            </a:r>
+            <a:r>
+              <a:rPr lang="en-US" dirty="0"/>
+              <a:t>(2)+y, with y in [-log(2)/2;log(2)/2). exp(x) = 2</a:t>
+            </a:r>
+            <a:r>
               <a:rPr lang="en-US" baseline="30000" dirty="0"/>
-              <a:t>e</a:t>
-            </a:r>
+              <a:t>k </a:t>
+            </a:r>
+            <a:r>
+              <a:rPr lang="en-US" dirty="0" err="1"/>
+              <a:t>ᐧexp</a:t>
+            </a:r>
+            <a:r>
+              <a:rPr lang="en-US" dirty="0"/>
+              <a:t>(y)</a:t>
+            </a:r>
+            <a:endParaRPr lang="en-US" baseline="30000" dirty="0"/>
           </a:p>
           <a:p>
             <a:pPr lvl="1"/>
             <a:r>
+              <a:rPr lang="en-US"/>
+              <a:t>For log(x):  </a:t>
+            </a:r>
+            <a:r>
               <a:rPr lang="en-US" dirty="0"/>
-              <a:t>For exp: compute 2exp(x) in [-log(2)/2;log(2)/2)</a:t>
-            </a:r>
-            <a:endParaRPr lang="en-US" baseline="30000" dirty="0"/>
+              <a:t>x =  yᐧ2</a:t>
+            </a:r>
+            <a:r>
+              <a:rPr lang="en-US" baseline="30000" dirty="0"/>
+              <a:t>z</a:t>
+            </a:r>
+            <a:r>
+              <a:rPr lang="en-US" dirty="0"/>
+              <a:t>, with  y in [0.75,1.5)</a:t>
+            </a:r>
+            <a:r>
+              <a:rPr lang="en-US" baseline="30000" dirty="0"/>
+              <a:t> </a:t>
+            </a:r>
+            <a:r>
+              <a:rPr lang="en-US" dirty="0"/>
+              <a:t>. log(x) = </a:t>
+            </a:r>
+            <a:r>
+              <a:rPr lang="en-US" dirty="0" err="1"/>
+              <a:t>zᐧlog</a:t>
+            </a:r>
+            <a:r>
+              <a:rPr lang="en-US" dirty="0"/>
+              <a:t>(2)+log(y) </a:t>
+            </a:r>
           </a:p>
           <a:p>
             <a:pPr lvl="1"/>
-            <a:r>
-              <a:rPr lang="en-US" dirty="0"/>
-              <a:t>For log: compute log</a:t>
-            </a:r>
-            <a:r>
-              <a:rPr lang="en-US" baseline="-25000" dirty="0"/>
-              <a:t>2</a:t>
-            </a:r>
-            <a:r>
-              <a:rPr lang="en-US" dirty="0"/>
-              <a:t>(x) in [0.75,1.5)</a:t>
-            </a:r>
-          </a:p>
-          <a:p>
-            <a:pPr lvl="1"/>
-            <a:r>
-              <a:rPr lang="en-US" dirty="0"/>
-              <a:t> </a:t>
-            </a:r>
             <a:r>
               <a:rPr lang="en-US" dirty="0" err="1"/>
               <a:t>x</a:t>
@@ -11451,15 +11698,15 @@
             </a:r>
             <a:r>
               <a:rPr lang="en-US" dirty="0"/>
-              <a:t>= 2</a:t>
-            </a:r>
-            <a:r>
-              <a:rPr lang="en-US" baseline="30000" dirty="0"/>
-              <a:t>ylog</a:t>
-            </a:r>
-            <a:r>
-              <a:rPr lang="en-US" baseline="-25000" dirty="0"/>
-              <a:t>2</a:t>
+              <a:t>= </a:t>
+            </a:r>
+            <a:r>
+              <a:rPr lang="en-US" dirty="0" err="1"/>
+              <a:t>e</a:t>
+            </a:r>
+            <a:r>
+              <a:rPr lang="en-US" baseline="30000" dirty="0" err="1"/>
+              <a:t>yᐧlog</a:t>
             </a:r>
             <a:r>
               <a:rPr lang="en-US" baseline="30000" dirty="0"/>
@@ -12537,17 +12784,8 @@
               <a:rPr lang="en-US" altLang="en-US" dirty="0">
                 <a:ea typeface="ＭＳ Ｐゴシック" panose="020B0600070205080204" pitchFamily="34" charset="-128"/>
               </a:rPr>
-              <a:t>The major contribution of game industry to SE is the discovery of the “magic” fast 1/√x algorithm </a:t>
-            </a:r>
-            <a:r>
-              <a:rPr lang="en-US" altLang="en-US">
-                <a:ea typeface="ＭＳ Ｐゴシック" panose="020B0600070205080204" pitchFamily="34" charset="-128"/>
-              </a:rPr>
-              <a:t>in quake3</a:t>
-            </a:r>
-            <a:endParaRPr lang="en-US" altLang="en-US" dirty="0">
-              <a:ea typeface="ＭＳ Ｐゴシック" panose="020B0600070205080204" pitchFamily="34" charset="-128"/>
-            </a:endParaRPr>
+              <a:t>The major contribution of game industry to SE is the discovery of the “magic” fast 1/√x algorithm in quake3</a:t>
+            </a:r>
           </a:p>
         </p:txBody>
       </p:sp>

</xml_diff>